<commit_message>
docs: team Firmat on the deck; recorded 77-second demo video with a hand-built CSV
- Firmat_Final.pptx: team slide with the four members and roles, group
  name Firmat throughout (file renamed to the TeamName_Final rule).
- demo/: hand-built synthetic waste export (SINTETIKE), the headless
  recorder (cursor, captions, CDP screencast -> ffmpeg), and the video
  sportel-demo.mp4: gap -> owner -> upload -> receipt -> KPI filled ->
  verified answer with source rows.
- VIDEO-SCRIPT.md with the storyboard; guide updated.

Co-Authored-By: Claude Opus 5.5 <noreply@anthropic.com>
</commit_message>
<xml_diff>
--- a/docs/pitch/final/Firmat_Final.pptx
+++ b/docs/pitch/final/Firmat_Final.pptx
@@ -510,7 +510,7 @@
             <a:r>
               <a:rPr lang="en-US" dirty="0"/>
               <a:t>[0:00–0:15]
-Good morning. We are FirmatGroup, and this is Sportel, for Challenge 02, the decision-making dashboard.
+Good morning. We are Firmat, and this is Sportel, for Challenge 02, the decision-making dashboard.
 Sportel gives every head of department numbers they can defend: every number, with its proof.</a:t>
             </a:r>
             <a:endParaRPr lang="en-US" dirty="0"/>
@@ -1150,7 +1150,7 @@
             <a:r>
               <a:rPr lang="en-US" dirty="0"/>
               <a:t>[4:35–4:45 · this slide stays up during Q&amp;A]
-We are FirmatGroup: [names]. Report once, prove every number. Thank you.</a:t>
+We are Firmat: Greisi, full stack; Redjon, AI; Martin, backend; Fatjon, DevOps. We built this full loop this weekend. Report once, prove every number. Thank you.</a:t>
             </a:r>
             <a:endParaRPr lang="en-US" dirty="0"/>
           </a:p>
@@ -1643,7 +1643,7 @@
                 <a:ea typeface="Arial" pitchFamily="34" charset="-122"/>
                 <a:cs typeface="Arial" pitchFamily="34" charset="-120"/>
               </a:rPr>
-              <a:t>Sportel · FirmatGroup</a:t>
+              <a:t>Sportel · Firmat</a:t>
             </a:r>
             <a:endParaRPr lang="en-US" sz="1100" dirty="0"/>
           </a:p>
@@ -1935,7 +1935,7 @@
                 <a:ea typeface="Arial" pitchFamily="34" charset="-122"/>
                 <a:cs typeface="Arial" pitchFamily="34" charset="-120"/>
               </a:rPr>
-              <a:t>FirmatGroup  ·  AI4Society Hackathon Tirana</a:t>
+              <a:t>Firmat  ·  AI4Society Hackathon Tirana</a:t>
             </a:r>
             <a:endParaRPr lang="en-US" sz="2000" dirty="0"/>
           </a:p>
@@ -2093,7 +2093,7 @@
                 <a:ea typeface="Arial" pitchFamily="34" charset="-122"/>
                 <a:cs typeface="Arial" pitchFamily="34" charset="-120"/>
               </a:rPr>
-              <a:t>Sportel · FirmatGroup</a:t>
+              <a:t>Sportel · Firmat</a:t>
             </a:r>
             <a:endParaRPr lang="en-US" sz="1100" dirty="0"/>
           </a:p>
@@ -2710,7 +2710,7 @@
                 <a:ea typeface="Arial" pitchFamily="34" charset="-122"/>
                 <a:cs typeface="Arial" pitchFamily="34" charset="-120"/>
               </a:rPr>
-              <a:t>Sportel · FirmatGroup</a:t>
+              <a:t>Sportel · Firmat</a:t>
             </a:r>
             <a:endParaRPr lang="en-US" sz="1100" dirty="0"/>
           </a:p>
@@ -3479,7 +3479,7 @@
                 <a:ea typeface="Arial" pitchFamily="34" charset="-122"/>
                 <a:cs typeface="Arial" pitchFamily="34" charset="-120"/>
               </a:rPr>
-              <a:t>Sportel · FirmatGroup</a:t>
+              <a:t>Sportel · Firmat</a:t>
             </a:r>
             <a:endParaRPr lang="en-US" sz="1100" dirty="0"/>
           </a:p>
@@ -4193,7 +4193,7 @@
                 <a:ea typeface="Arial" pitchFamily="34" charset="-122"/>
                 <a:cs typeface="Arial" pitchFamily="34" charset="-120"/>
               </a:rPr>
-              <a:t>Sportel · FirmatGroup</a:t>
+              <a:t>Sportel · Firmat</a:t>
             </a:r>
             <a:endParaRPr lang="en-US" sz="1100" dirty="0"/>
           </a:p>
@@ -4930,7 +4930,7 @@
                 <a:ea typeface="Arial" pitchFamily="34" charset="-122"/>
                 <a:cs typeface="Arial" pitchFamily="34" charset="-120"/>
               </a:rPr>
-              <a:t>Sportel · FirmatGroup</a:t>
+              <a:t>Sportel · Firmat</a:t>
             </a:r>
             <a:endParaRPr lang="en-US" sz="1100" dirty="0"/>
           </a:p>
@@ -5520,7 +5520,7 @@
                 <a:ea typeface="Arial" pitchFamily="34" charset="-122"/>
                 <a:cs typeface="Arial" pitchFamily="34" charset="-120"/>
               </a:rPr>
-              <a:t>Sportel · FirmatGroup</a:t>
+              <a:t>Sportel · Firmat</a:t>
             </a:r>
             <a:endParaRPr lang="en-US" sz="1100" dirty="0"/>
           </a:p>
@@ -6813,7 +6813,7 @@
                 <a:ea typeface="Arial" pitchFamily="34" charset="-122"/>
                 <a:cs typeface="Arial" pitchFamily="34" charset="-120"/>
               </a:rPr>
-              <a:t>Sportel · FirmatGroup</a:t>
+              <a:t>Sportel · Firmat</a:t>
             </a:r>
             <a:endParaRPr lang="en-US" sz="1100" dirty="0"/>
           </a:p>
@@ -6891,7 +6891,7 @@
                 <a:ea typeface="Arial" pitchFamily="34" charset="-122"/>
                 <a:cs typeface="Arial" pitchFamily="34" charset="-120"/>
               </a:rPr>
-              <a:t>FirmatGroup</a:t>
+              <a:t>Firmat</a:t>
             </a:r>
             <a:endParaRPr lang="en-US" sz="4000" dirty="0"/>
           </a:p>
@@ -6981,8 +6981,8 @@
         </p:nvSpPr>
         <p:spPr>
           <a:xfrm>
-            <a:off x="731520" y="3520440"/>
-            <a:ext cx="2156384" cy="411480"/>
+            <a:off x="685800" y="3474720"/>
+            <a:ext cx="2293544" cy="411480"/>
           </a:xfrm>
           <a:prstGeom prst="rect">
             <a:avLst/>
@@ -6998,7 +6998,7 @@
               <a:buNone/>
             </a:pPr>
             <a:r>
-              <a:rPr lang="en-US" sz="2200" b="1" dirty="0">
+              <a:rPr lang="en-US" sz="1800" b="1" dirty="0">
                 <a:solidFill>
                   <a:srgbClr val="1C2B5A"/>
                 </a:solidFill>
@@ -7006,9 +7006,9 @@
                 <a:ea typeface="Arial" pitchFamily="34" charset="-122"/>
                 <a:cs typeface="Arial" pitchFamily="34" charset="-120"/>
               </a:rPr>
-              <a:t>[Name]</a:t>
-            </a:r>
-            <a:endParaRPr lang="en-US" sz="2200" dirty="0"/>
+              <a:t>Greisi Kertuka</a:t>
+            </a:r>
+            <a:endParaRPr lang="en-US" sz="1800" dirty="0"/>
           </a:p>
         </p:txBody>
       </p:sp>
@@ -7020,8 +7020,8 @@
         </p:nvSpPr>
         <p:spPr>
           <a:xfrm>
-            <a:off x="731520" y="3931920"/>
-            <a:ext cx="2156384" cy="411480"/>
+            <a:off x="685800" y="3858768"/>
+            <a:ext cx="2293544" cy="548640"/>
           </a:xfrm>
           <a:prstGeom prst="rect">
             <a:avLst/>
@@ -7037,7 +7037,7 @@
               <a:buNone/>
             </a:pPr>
             <a:r>
-              <a:rPr lang="en-US" sz="1800" dirty="0">
+              <a:rPr lang="en-US" sz="1600" dirty="0">
                 <a:solidFill>
                   <a:srgbClr val="6B7280"/>
                 </a:solidFill>
@@ -7045,9 +7045,9 @@
                 <a:ea typeface="Arial" pitchFamily="34" charset="-122"/>
                 <a:cs typeface="Arial" pitchFamily="34" charset="-120"/>
               </a:rPr>
-              <a:t>Problem &amp; users</a:t>
-            </a:r>
-            <a:endParaRPr lang="en-US" sz="1800" dirty="0"/>
+              <a:t>Full Stack Developer</a:t>
+            </a:r>
+            <a:endParaRPr lang="en-US" sz="1600" dirty="0"/>
           </a:p>
         </p:txBody>
       </p:sp>
@@ -7135,8 +7135,8 @@
         </p:nvSpPr>
         <p:spPr>
           <a:xfrm>
-            <a:off x="3619424" y="3520440"/>
-            <a:ext cx="2156384" cy="411480"/>
+            <a:off x="3573704" y="3474720"/>
+            <a:ext cx="2293544" cy="411480"/>
           </a:xfrm>
           <a:prstGeom prst="rect">
             <a:avLst/>
@@ -7152,7 +7152,7 @@
               <a:buNone/>
             </a:pPr>
             <a:r>
-              <a:rPr lang="en-US" sz="2200" b="1" dirty="0">
+              <a:rPr lang="en-US" sz="1800" b="1" dirty="0">
                 <a:solidFill>
                   <a:srgbClr val="1C2B5A"/>
                 </a:solidFill>
@@ -7160,9 +7160,9 @@
                 <a:ea typeface="Arial" pitchFamily="34" charset="-122"/>
                 <a:cs typeface="Arial" pitchFamily="34" charset="-120"/>
               </a:rPr>
-              <a:t>[Name]</a:t>
-            </a:r>
-            <a:endParaRPr lang="en-US" sz="2200" dirty="0"/>
+              <a:t>Redjon Mezani</a:t>
+            </a:r>
+            <a:endParaRPr lang="en-US" sz="1800" dirty="0"/>
           </a:p>
         </p:txBody>
       </p:sp>
@@ -7174,8 +7174,8 @@
         </p:nvSpPr>
         <p:spPr>
           <a:xfrm>
-            <a:off x="3619424" y="3931920"/>
-            <a:ext cx="2156384" cy="411480"/>
+            <a:off x="3573704" y="3858768"/>
+            <a:ext cx="2293544" cy="548640"/>
           </a:xfrm>
           <a:prstGeom prst="rect">
             <a:avLst/>
@@ -7191,7 +7191,7 @@
               <a:buNone/>
             </a:pPr>
             <a:r>
-              <a:rPr lang="en-US" sz="1800" dirty="0">
+              <a:rPr lang="en-US" sz="1600" dirty="0">
                 <a:solidFill>
                   <a:srgbClr val="6B7280"/>
                 </a:solidFill>
@@ -7199,9 +7199,9 @@
                 <a:ea typeface="Arial" pitchFamily="34" charset="-122"/>
                 <a:cs typeface="Arial" pitchFamily="34" charset="-120"/>
               </a:rPr>
-              <a:t>Demo &amp; product</a:t>
-            </a:r>
-            <a:endParaRPr lang="en-US" sz="1800" dirty="0"/>
+              <a:t>AI Engineer</a:t>
+            </a:r>
+            <a:endParaRPr lang="en-US" sz="1600" dirty="0"/>
           </a:p>
         </p:txBody>
       </p:sp>
@@ -7289,8 +7289,8 @@
         </p:nvSpPr>
         <p:spPr>
           <a:xfrm>
-            <a:off x="6507328" y="3520440"/>
-            <a:ext cx="2156384" cy="411480"/>
+            <a:off x="6461608" y="3474720"/>
+            <a:ext cx="2293544" cy="411480"/>
           </a:xfrm>
           <a:prstGeom prst="rect">
             <a:avLst/>
@@ -7306,7 +7306,7 @@
               <a:buNone/>
             </a:pPr>
             <a:r>
-              <a:rPr lang="en-US" sz="2200" b="1" dirty="0">
+              <a:rPr lang="en-US" sz="1800" b="1" dirty="0">
                 <a:solidFill>
                   <a:srgbClr val="1C2B5A"/>
                 </a:solidFill>
@@ -7314,9 +7314,9 @@
                 <a:ea typeface="Arial" pitchFamily="34" charset="-122"/>
                 <a:cs typeface="Arial" pitchFamily="34" charset="-120"/>
               </a:rPr>
-              <a:t>[Name]</a:t>
-            </a:r>
-            <a:endParaRPr lang="en-US" sz="2200" dirty="0"/>
+              <a:t>Martin Shembitraku</a:t>
+            </a:r>
+            <a:endParaRPr lang="en-US" sz="1800" dirty="0"/>
           </a:p>
         </p:txBody>
       </p:sp>
@@ -7328,8 +7328,8 @@
         </p:nvSpPr>
         <p:spPr>
           <a:xfrm>
-            <a:off x="6507328" y="3931920"/>
-            <a:ext cx="2156384" cy="411480"/>
+            <a:off x="6461608" y="3858768"/>
+            <a:ext cx="2293544" cy="548640"/>
           </a:xfrm>
           <a:prstGeom prst="rect">
             <a:avLst/>
@@ -7345,7 +7345,7 @@
               <a:buNone/>
             </a:pPr>
             <a:r>
-              <a:rPr lang="en-US" sz="1800" dirty="0">
+              <a:rPr lang="en-US" sz="1600" dirty="0">
                 <a:solidFill>
                   <a:srgbClr val="6B7280"/>
                 </a:solidFill>
@@ -7353,9 +7353,9 @@
                 <a:ea typeface="Arial" pitchFamily="34" charset="-122"/>
                 <a:cs typeface="Arial" pitchFamily="34" charset="-120"/>
               </a:rPr>
-              <a:t>Data &amp; AI</a:t>
-            </a:r>
-            <a:endParaRPr lang="en-US" sz="1800" dirty="0"/>
+              <a:t>Backend Developer</a:t>
+            </a:r>
+            <a:endParaRPr lang="en-US" sz="1600" dirty="0"/>
           </a:p>
         </p:txBody>
       </p:sp>
@@ -7443,8 +7443,8 @@
         </p:nvSpPr>
         <p:spPr>
           <a:xfrm>
-            <a:off x="9395231" y="3520440"/>
-            <a:ext cx="2156384" cy="411480"/>
+            <a:off x="9349511" y="3474720"/>
+            <a:ext cx="2293544" cy="411480"/>
           </a:xfrm>
           <a:prstGeom prst="rect">
             <a:avLst/>
@@ -7460,7 +7460,7 @@
               <a:buNone/>
             </a:pPr>
             <a:r>
-              <a:rPr lang="en-US" sz="2200" b="1" dirty="0">
+              <a:rPr lang="en-US" sz="1800" b="1" dirty="0">
                 <a:solidFill>
                   <a:srgbClr val="1C2B5A"/>
                 </a:solidFill>
@@ -7468,9 +7468,9 @@
                 <a:ea typeface="Arial" pitchFamily="34" charset="-122"/>
                 <a:cs typeface="Arial" pitchFamily="34" charset="-120"/>
               </a:rPr>
-              <a:t>[Name]</a:t>
-            </a:r>
-            <a:endParaRPr lang="en-US" sz="2200" dirty="0"/>
+              <a:t>Fatjon Omeri</a:t>
+            </a:r>
+            <a:endParaRPr lang="en-US" sz="1800" dirty="0"/>
           </a:p>
         </p:txBody>
       </p:sp>
@@ -7482,8 +7482,8 @@
         </p:nvSpPr>
         <p:spPr>
           <a:xfrm>
-            <a:off x="9395231" y="3931920"/>
-            <a:ext cx="2156384" cy="411480"/>
+            <a:off x="9349511" y="3858768"/>
+            <a:ext cx="2293544" cy="548640"/>
           </a:xfrm>
           <a:prstGeom prst="rect">
             <a:avLst/>
@@ -7499,7 +7499,7 @@
               <a:buNone/>
             </a:pPr>
             <a:r>
-              <a:rPr lang="en-US" sz="1800" dirty="0">
+              <a:rPr lang="en-US" sz="1600" dirty="0">
                 <a:solidFill>
                   <a:srgbClr val="6B7280"/>
                 </a:solidFill>
@@ -7507,9 +7507,9 @@
                 <a:ea typeface="Arial" pitchFamily="34" charset="-122"/>
                 <a:cs typeface="Arial" pitchFamily="34" charset="-120"/>
               </a:rPr>
-              <a:t>Testing</a:t>
-            </a:r>
-            <a:endParaRPr lang="en-US" sz="1800" dirty="0"/>
+              <a:t>DevOps &amp; Full Stack Developer</a:t>
+            </a:r>
+            <a:endParaRPr lang="en-US" sz="1600" dirty="0"/>
           </a:p>
         </p:txBody>
       </p:sp>

</xml_diff>